<commit_message>
Update diffusion slides to latest version (43 slides)
</commit_message>
<xml_diff>
--- a/diffusion/diffusion_models_polished.pptx
+++ b/diffusion/diffusion_models_polished.pptx
@@ -47,6 +47,7 @@
     <p:sldId id="295" r:id="rId46"/>
     <p:sldId id="296" r:id="rId47"/>
     <p:sldId id="297" r:id="rId48"/>
+    <p:sldId id="298" r:id="rId49"/>
   </p:sldIdLst>
   <p:sldSz cx="12191695" cy="6858000" type="screen4x3"/>
   <p:notesSz cx="6858000" cy="9144000"/>
@@ -4121,7 +4122,7 @@
                 </a:solidFill>
                 <a:latin typeface="Arial"/>
               </a:rPr>
-              <a:t>10 / 42</a:t>
+              <a:t>10 / 43</a:t>
             </a:r>
           </a:p>
         </p:txBody>
@@ -5047,7 +5048,7 @@
                 </a:solidFill>
                 <a:latin typeface="Arial"/>
               </a:rPr>
-              <a:t>11 / 42</a:t>
+              <a:t>11 / 43</a:t>
             </a:r>
           </a:p>
         </p:txBody>
@@ -5886,6 +5887,41 @@
         </p:nvSpPr>
         <p:spPr>
           <a:xfrm>
+            <a:off x="566928" y="6400800"/>
+            <a:ext cx="6858000" cy="274320"/>
+          </a:xfrm>
+          <a:prstGeom prst="rect">
+            <a:avLst/>
+          </a:prstGeom>
+          <a:noFill/>
+        </p:spPr>
+        <p:txBody>
+          <a:bodyPr wrap="square" anchor="t" lIns="0" rIns="0" tIns="0" bIns="0">
+            <a:spAutoFit/>
+          </a:bodyPr>
+          <a:lstStyle/>
+          <a:p>
+            <a:pPr algn="l"/>
+            <a:r>
+              <a:rPr sz="1000" b="0" i="0" spc="30">
+                <a:solidFill>
+                  <a:srgbClr val="8A909C"/>
+                </a:solidFill>
+                <a:latin typeface="Arial"/>
+              </a:rPr>
+              <a:t>[4]  Hyvärinen, 2005</a:t>
+            </a:r>
+          </a:p>
+        </p:txBody>
+      </p:sp>
+      <p:sp>
+        <p:nvSpPr>
+          <p:cNvPr id="17" name="TextBox 16"/>
+          <p:cNvSpPr txBox="1"/>
+          <p:nvPr/>
+        </p:nvSpPr>
+        <p:spPr>
+          <a:xfrm>
             <a:off x="10820095" y="6400800"/>
             <a:ext cx="914400" cy="274320"/>
           </a:xfrm>
@@ -5908,7 +5944,7 @@
                 </a:solidFill>
                 <a:latin typeface="Arial"/>
               </a:rPr>
-              <a:t>13 / 42</a:t>
+              <a:t>13 / 43</a:t>
             </a:r>
           </a:p>
         </p:txBody>
@@ -6627,7 +6663,7 @@
                 </a:solidFill>
                 <a:latin typeface="Arial"/>
               </a:rPr>
-              <a:t>14 / 42</a:t>
+              <a:t>14 / 43</a:t>
             </a:r>
           </a:p>
         </p:txBody>
@@ -7170,7 +7206,7 @@
                 </a:solidFill>
                 <a:latin typeface="Arial"/>
               </a:rPr>
-              <a:t>15 / 42</a:t>
+              <a:t>15 / 43</a:t>
             </a:r>
           </a:p>
         </p:txBody>
@@ -7897,6 +7933,41 @@
         </p:nvSpPr>
         <p:spPr>
           <a:xfrm>
+            <a:off x="566928" y="6400800"/>
+            <a:ext cx="6858000" cy="274320"/>
+          </a:xfrm>
+          <a:prstGeom prst="rect">
+            <a:avLst/>
+          </a:prstGeom>
+          <a:noFill/>
+        </p:spPr>
+        <p:txBody>
+          <a:bodyPr wrap="square" anchor="t" lIns="0" rIns="0" tIns="0" bIns="0">
+            <a:spAutoFit/>
+          </a:bodyPr>
+          <a:lstStyle/>
+          <a:p>
+            <a:pPr algn="l"/>
+            <a:r>
+              <a:rPr sz="1000" b="0" i="0" spc="30">
+                <a:solidFill>
+                  <a:srgbClr val="8A909C"/>
+                </a:solidFill>
+                <a:latin typeface="Arial"/>
+              </a:rPr>
+              <a:t>[5]  Hutchinson, 1990</a:t>
+            </a:r>
+          </a:p>
+        </p:txBody>
+      </p:sp>
+      <p:sp>
+        <p:nvSpPr>
+          <p:cNvPr id="15" name="TextBox 14"/>
+          <p:cNvSpPr txBox="1"/>
+          <p:nvPr/>
+        </p:nvSpPr>
+        <p:spPr>
+          <a:xfrm>
             <a:off x="10820095" y="6400800"/>
             <a:ext cx="914400" cy="274320"/>
           </a:xfrm>
@@ -7919,7 +7990,7 @@
                 </a:solidFill>
                 <a:latin typeface="Arial"/>
               </a:rPr>
-              <a:t>17 / 42</a:t>
+              <a:t>17 / 43</a:t>
             </a:r>
           </a:p>
         </p:txBody>
@@ -8818,7 +8889,7 @@
                 </a:solidFill>
                 <a:latin typeface="Arial"/>
               </a:rPr>
-              <a:t>18 / 42</a:t>
+              <a:t>18 / 43</a:t>
             </a:r>
           </a:p>
         </p:txBody>
@@ -9416,6 +9487,41 @@
         </p:nvSpPr>
         <p:spPr>
           <a:xfrm>
+            <a:off x="566928" y="6400800"/>
+            <a:ext cx="6858000" cy="274320"/>
+          </a:xfrm>
+          <a:prstGeom prst="rect">
+            <a:avLst/>
+          </a:prstGeom>
+          <a:noFill/>
+        </p:spPr>
+        <p:txBody>
+          <a:bodyPr wrap="square" anchor="t" lIns="0" rIns="0" tIns="0" bIns="0">
+            <a:spAutoFit/>
+          </a:bodyPr>
+          <a:lstStyle/>
+          <a:p>
+            <a:pPr algn="l"/>
+            <a:r>
+              <a:rPr sz="1000" b="0" i="0" spc="30">
+                <a:solidFill>
+                  <a:srgbClr val="8A909C"/>
+                </a:solidFill>
+                <a:latin typeface="Arial"/>
+              </a:rPr>
+              <a:t>[6]  Song, Garg, Shi &amp; Ermon, 2019</a:t>
+            </a:r>
+          </a:p>
+        </p:txBody>
+      </p:sp>
+      <p:sp>
+        <p:nvSpPr>
+          <p:cNvPr id="16" name="TextBox 15"/>
+          <p:cNvSpPr txBox="1"/>
+          <p:nvPr/>
+        </p:nvSpPr>
+        <p:spPr>
+          <a:xfrm>
             <a:off x="10820095" y="6400800"/>
             <a:ext cx="914400" cy="274320"/>
           </a:xfrm>
@@ -9438,7 +9544,7 @@
                 </a:solidFill>
                 <a:latin typeface="Arial"/>
               </a:rPr>
-              <a:t>19 / 42</a:t>
+              <a:t>19 / 43</a:t>
             </a:r>
           </a:p>
         </p:txBody>
@@ -10498,7 +10604,7 @@
                 </a:solidFill>
                 <a:latin typeface="Arial"/>
               </a:rPr>
-              <a:t>02 / 42</a:t>
+              <a:t>02 / 43</a:t>
             </a:r>
           </a:p>
         </p:txBody>
@@ -11093,7 +11199,7 @@
                 </a:solidFill>
                 <a:latin typeface="Arial"/>
               </a:rPr>
-              <a:t>20 / 42</a:t>
+              <a:t>20 / 43</a:t>
             </a:r>
           </a:p>
         </p:txBody>
@@ -11890,7 +11996,7 @@
                 </a:solidFill>
                 <a:latin typeface="Arial"/>
               </a:rPr>
-              <a:t>22 / 42</a:t>
+              <a:t>22 / 43</a:t>
             </a:r>
           </a:p>
         </p:txBody>
@@ -12627,6 +12733,41 @@
         </p:nvSpPr>
         <p:spPr>
           <a:xfrm>
+            <a:off x="566928" y="6400800"/>
+            <a:ext cx="6858000" cy="274320"/>
+          </a:xfrm>
+          <a:prstGeom prst="rect">
+            <a:avLst/>
+          </a:prstGeom>
+          <a:noFill/>
+        </p:spPr>
+        <p:txBody>
+          <a:bodyPr wrap="square" anchor="t" lIns="0" rIns="0" tIns="0" bIns="0">
+            <a:spAutoFit/>
+          </a:bodyPr>
+          <a:lstStyle/>
+          <a:p>
+            <a:pPr algn="l"/>
+            <a:r>
+              <a:rPr sz="1000" b="0" i="0" spc="30">
+                <a:solidFill>
+                  <a:srgbClr val="8A909C"/>
+                </a:solidFill>
+                <a:latin typeface="Arial"/>
+              </a:rPr>
+              <a:t>[7]  Vincent, Larochelle, Bengio &amp; Manzagol, 2008</a:t>
+            </a:r>
+          </a:p>
+        </p:txBody>
+      </p:sp>
+      <p:sp>
+        <p:nvSpPr>
+          <p:cNvPr id="19" name="TextBox 18"/>
+          <p:cNvSpPr txBox="1"/>
+          <p:nvPr/>
+        </p:nvSpPr>
+        <p:spPr>
+          <a:xfrm>
             <a:off x="10820095" y="6400800"/>
             <a:ext cx="914400" cy="274320"/>
           </a:xfrm>
@@ -12649,7 +12790,7 @@
                 </a:solidFill>
                 <a:latin typeface="Arial"/>
               </a:rPr>
-              <a:t>23 / 42</a:t>
+              <a:t>23 / 43</a:t>
             </a:r>
           </a:p>
         </p:txBody>
@@ -13014,6 +13155,41 @@
         </p:nvSpPr>
         <p:spPr>
           <a:xfrm>
+            <a:off x="566928" y="6400800"/>
+            <a:ext cx="6858000" cy="274320"/>
+          </a:xfrm>
+          <a:prstGeom prst="rect">
+            <a:avLst/>
+          </a:prstGeom>
+          <a:noFill/>
+        </p:spPr>
+        <p:txBody>
+          <a:bodyPr wrap="square" anchor="t" lIns="0" rIns="0" tIns="0" bIns="0">
+            <a:spAutoFit/>
+          </a:bodyPr>
+          <a:lstStyle/>
+          <a:p>
+            <a:pPr algn="l"/>
+            <a:r>
+              <a:rPr sz="1000" b="0" i="0" spc="30">
+                <a:solidFill>
+                  <a:srgbClr val="8A909C"/>
+                </a:solidFill>
+                <a:latin typeface="Arial"/>
+              </a:rPr>
+              <a:t>[8]  Vincent, 2011</a:t>
+            </a:r>
+          </a:p>
+        </p:txBody>
+      </p:sp>
+      <p:sp>
+        <p:nvSpPr>
+          <p:cNvPr id="11" name="TextBox 10"/>
+          <p:cNvSpPr txBox="1"/>
+          <p:nvPr/>
+        </p:nvSpPr>
+        <p:spPr>
+          <a:xfrm>
             <a:off x="10820095" y="6400800"/>
             <a:ext cx="914400" cy="274320"/>
           </a:xfrm>
@@ -13036,7 +13212,7 @@
                 </a:solidFill>
                 <a:latin typeface="Arial"/>
               </a:rPr>
-              <a:t>24 / 42</a:t>
+              <a:t>24 / 43</a:t>
             </a:r>
           </a:p>
         </p:txBody>
@@ -13640,7 +13816,7 @@
                 </a:solidFill>
                 <a:latin typeface="Arial"/>
               </a:rPr>
-              <a:t>25 / 42</a:t>
+              <a:t>25 / 43</a:t>
             </a:r>
           </a:p>
         </p:txBody>
@@ -14629,6 +14805,41 @@
         </p:nvSpPr>
         <p:spPr>
           <a:xfrm>
+            <a:off x="566928" y="6400800"/>
+            <a:ext cx="6858000" cy="274320"/>
+          </a:xfrm>
+          <a:prstGeom prst="rect">
+            <a:avLst/>
+          </a:prstGeom>
+          <a:noFill/>
+        </p:spPr>
+        <p:txBody>
+          <a:bodyPr wrap="square" anchor="t" lIns="0" rIns="0" tIns="0" bIns="0">
+            <a:spAutoFit/>
+          </a:bodyPr>
+          <a:lstStyle/>
+          <a:p>
+            <a:pPr algn="l"/>
+            <a:r>
+              <a:rPr sz="1000" b="0" i="0" spc="30">
+                <a:solidFill>
+                  <a:srgbClr val="8A909C"/>
+                </a:solidFill>
+                <a:latin typeface="Arial"/>
+              </a:rPr>
+              <a:t>[11]  Song &amp; Ermon, 2019</a:t>
+            </a:r>
+          </a:p>
+        </p:txBody>
+      </p:sp>
+      <p:sp>
+        <p:nvSpPr>
+          <p:cNvPr id="27" name="TextBox 26"/>
+          <p:cNvSpPr txBox="1"/>
+          <p:nvPr/>
+        </p:nvSpPr>
+        <p:spPr>
+          <a:xfrm>
             <a:off x="10820095" y="6400800"/>
             <a:ext cx="914400" cy="274320"/>
           </a:xfrm>
@@ -14651,7 +14862,7 @@
                 </a:solidFill>
                 <a:latin typeface="Arial"/>
               </a:rPr>
-              <a:t>26 / 42</a:t>
+              <a:t>26 / 43</a:t>
             </a:r>
           </a:p>
         </p:txBody>
@@ -15426,6 +15637,41 @@
         </p:nvSpPr>
         <p:spPr>
           <a:xfrm>
+            <a:off x="566928" y="6400800"/>
+            <a:ext cx="6858000" cy="274320"/>
+          </a:xfrm>
+          <a:prstGeom prst="rect">
+            <a:avLst/>
+          </a:prstGeom>
+          <a:noFill/>
+        </p:spPr>
+        <p:txBody>
+          <a:bodyPr wrap="square" anchor="t" lIns="0" rIns="0" tIns="0" bIns="0">
+            <a:spAutoFit/>
+          </a:bodyPr>
+          <a:lstStyle/>
+          <a:p>
+            <a:pPr algn="l"/>
+            <a:r>
+              <a:rPr sz="1000" b="0" i="0" spc="30">
+                <a:solidFill>
+                  <a:srgbClr val="8A909C"/>
+                </a:solidFill>
+                <a:latin typeface="Arial"/>
+              </a:rPr>
+              <a:t>[12]  Ho, Jain &amp; Abbeel, 2020</a:t>
+            </a:r>
+          </a:p>
+        </p:txBody>
+      </p:sp>
+      <p:sp>
+        <p:nvSpPr>
+          <p:cNvPr id="16" name="TextBox 15"/>
+          <p:cNvSpPr txBox="1"/>
+          <p:nvPr/>
+        </p:nvSpPr>
+        <p:spPr>
+          <a:xfrm>
             <a:off x="10820095" y="6400800"/>
             <a:ext cx="914400" cy="274320"/>
           </a:xfrm>
@@ -15448,7 +15694,7 @@
                 </a:solidFill>
                 <a:latin typeface="Arial"/>
               </a:rPr>
-              <a:t>28 / 42</a:t>
+              <a:t>28 / 43</a:t>
             </a:r>
           </a:p>
         </p:txBody>
@@ -15740,7 +15986,7 @@
                 </a:solidFill>
                 <a:latin typeface="Arial"/>
               </a:rPr>
-              <a:t>29 / 42</a:t>
+              <a:t>29 / 43</a:t>
             </a:r>
           </a:p>
         </p:txBody>
@@ -16515,6 +16761,41 @@
         </p:nvSpPr>
         <p:spPr>
           <a:xfrm>
+            <a:off x="566928" y="6400800"/>
+            <a:ext cx="6858000" cy="274320"/>
+          </a:xfrm>
+          <a:prstGeom prst="rect">
+            <a:avLst/>
+          </a:prstGeom>
+          <a:noFill/>
+        </p:spPr>
+        <p:txBody>
+          <a:bodyPr wrap="square" anchor="t" lIns="0" rIns="0" tIns="0" bIns="0">
+            <a:spAutoFit/>
+          </a:bodyPr>
+          <a:lstStyle/>
+          <a:p>
+            <a:pPr algn="l"/>
+            <a:r>
+              <a:rPr sz="1000" b="0" i="0" spc="30">
+                <a:solidFill>
+                  <a:srgbClr val="8A909C"/>
+                </a:solidFill>
+                <a:latin typeface="Arial"/>
+              </a:rPr>
+              <a:t>[10]  Welling &amp; Teh, 2011</a:t>
+            </a:r>
+          </a:p>
+        </p:txBody>
+      </p:sp>
+      <p:sp>
+        <p:nvSpPr>
+          <p:cNvPr id="16" name="TextBox 15"/>
+          <p:cNvSpPr txBox="1"/>
+          <p:nvPr/>
+        </p:nvSpPr>
+        <p:spPr>
+          <a:xfrm>
             <a:off x="10820095" y="6400800"/>
             <a:ext cx="914400" cy="274320"/>
           </a:xfrm>
@@ -16537,7 +16818,7 @@
                 </a:solidFill>
                 <a:latin typeface="Arial"/>
               </a:rPr>
-              <a:t>30 / 42</a:t>
+              <a:t>30 / 43</a:t>
             </a:r>
           </a:p>
         </p:txBody>
@@ -17332,7 +17613,7 @@
                 </a:solidFill>
                 <a:latin typeface="Arial"/>
               </a:rPr>
-              <a:t>31 / 42</a:t>
+              <a:t>31 / 43</a:t>
             </a:r>
           </a:p>
         </p:txBody>
@@ -18281,7 +18562,7 @@
                 </a:solidFill>
                 <a:latin typeface="Arial"/>
               </a:rPr>
-              <a:t>33 / 42</a:t>
+              <a:t>33 / 43</a:t>
             </a:r>
           </a:p>
         </p:txBody>
@@ -18866,7 +19147,7 @@
                 </a:solidFill>
                 <a:latin typeface="Arial"/>
               </a:rPr>
-              <a:t>34 / 42</a:t>
+              <a:t>34 / 43</a:t>
             </a:r>
           </a:p>
         </p:txBody>
@@ -19580,7 +19861,7 @@
                 </a:solidFill>
                 <a:latin typeface="Arial"/>
               </a:rPr>
-              <a:t>35 / 42</a:t>
+              <a:t>35 / 43</a:t>
             </a:r>
           </a:p>
         </p:txBody>
@@ -20130,7 +20411,7 @@
                 </a:solidFill>
                 <a:latin typeface="Arial"/>
               </a:rPr>
-              <a:t>36 / 42</a:t>
+              <a:t>36 / 43</a:t>
             </a:r>
           </a:p>
         </p:txBody>
@@ -20656,7 +20937,7 @@
                 </a:solidFill>
                 <a:latin typeface="Arial"/>
               </a:rPr>
-              <a:t>37 / 42</a:t>
+              <a:t>37 / 43</a:t>
             </a:r>
           </a:p>
         </p:txBody>
@@ -21217,7 +21498,7 @@
                 </a:solidFill>
                 <a:latin typeface="Arial"/>
               </a:rPr>
-              <a:t>38 / 42</a:t>
+              <a:t>38 / 43</a:t>
             </a:r>
           </a:p>
         </p:txBody>
@@ -21877,7 +22158,7 @@
                 </a:solidFill>
                 <a:latin typeface="Arial"/>
               </a:rPr>
-              <a:t>39 / 42</a:t>
+              <a:t>39 / 43</a:t>
             </a:r>
           </a:p>
         </p:txBody>
@@ -22690,7 +22971,7 @@
                 </a:solidFill>
                 <a:latin typeface="Arial"/>
               </a:rPr>
-              <a:t>04 / 42</a:t>
+              <a:t>04 / 43</a:t>
             </a:r>
           </a:p>
         </p:txBody>
@@ -23784,7 +24065,7 @@
                 </a:solidFill>
                 <a:latin typeface="Arial"/>
               </a:rPr>
-              <a:t>40 / 42</a:t>
+              <a:t>40 / 43</a:t>
             </a:r>
           </a:p>
         </p:txBody>
@@ -24357,7 +24638,7 @@
                 </a:solidFill>
                 <a:latin typeface="Arial"/>
               </a:rPr>
-              <a:t>41 / 42</a:t>
+              <a:t>41 / 43</a:t>
             </a:r>
           </a:p>
         </p:txBody>
@@ -24956,7 +25237,829 @@
                 </a:solidFill>
                 <a:latin typeface="Arial"/>
               </a:rPr>
-              <a:t>42 / 42</a:t>
+              <a:t>42 / 43</a:t>
+            </a:r>
+          </a:p>
+        </p:txBody>
+      </p:sp>
+    </p:spTree>
+  </p:cSld>
+  <p:clrMapOvr>
+    <a:masterClrMapping/>
+  </p:clrMapOvr>
+</p:sld>
+</file>
+
+<file path=ppt/slides/slide43.xml><?xml version="1.0" encoding="utf-8"?>
+<p:sld xmlns:a="http://schemas.openxmlformats.org/drawingml/2006/main" xmlns:p="http://schemas.openxmlformats.org/presentationml/2006/main" xmlns:r="http://schemas.openxmlformats.org/officeDocument/2006/relationships">
+  <p:cSld>
+    <p:spTree>
+      <p:nvGrpSpPr>
+        <p:cNvPr id="1" name=""/>
+        <p:cNvGrpSpPr/>
+        <p:nvPr/>
+      </p:nvGrpSpPr>
+      <p:grpSpPr/>
+      <p:sp>
+        <p:nvSpPr>
+          <p:cNvPr id="2" name="Rectangle 1"/>
+          <p:cNvSpPr/>
+          <p:nvPr/>
+        </p:nvSpPr>
+        <p:spPr>
+          <a:xfrm>
+            <a:off x="0" y="0"/>
+            <a:ext cx="12191695" cy="6858000"/>
+          </a:xfrm>
+          <a:prstGeom prst="rect">
+            <a:avLst/>
+          </a:prstGeom>
+          <a:solidFill>
+            <a:srgbClr val="F4F5F7"/>
+          </a:solidFill>
+          <a:ln>
+            <a:noFill/>
+          </a:ln>
+          <a:effectLst/>
+        </p:spPr>
+        <p:style>
+          <a:lnRef idx="1">
+            <a:schemeClr val="accent1"/>
+          </a:lnRef>
+          <a:fillRef idx="3">
+            <a:schemeClr val="accent1"/>
+          </a:fillRef>
+          <a:effectRef idx="2">
+            <a:schemeClr val="accent1"/>
+          </a:effectRef>
+          <a:fontRef idx="minor">
+            <a:schemeClr val="lt1"/>
+          </a:fontRef>
+        </p:style>
+        <p:txBody>
+          <a:bodyPr rtlCol="0" anchor="ctr"/>
+          <a:lstStyle/>
+          <a:p>
+            <a:pPr algn="ctr"/>
+          </a:p>
+        </p:txBody>
+      </p:sp>
+      <p:sp>
+        <p:nvSpPr>
+          <p:cNvPr id="3" name="Rounded Rectangle 2"/>
+          <p:cNvSpPr/>
+          <p:nvPr/>
+        </p:nvSpPr>
+        <p:spPr>
+          <a:xfrm>
+            <a:off x="566928" y="420624"/>
+            <a:ext cx="118872" cy="566928"/>
+          </a:xfrm>
+          <a:prstGeom prst="roundRect">
+            <a:avLst>
+              <a:gd name="adj" fmla="val 50000"/>
+            </a:avLst>
+          </a:prstGeom>
+          <a:solidFill>
+            <a:srgbClr val="5B5BD6"/>
+          </a:solidFill>
+          <a:ln>
+            <a:noFill/>
+          </a:ln>
+          <a:effectLst/>
+        </p:spPr>
+        <p:style>
+          <a:lnRef idx="1">
+            <a:schemeClr val="accent1"/>
+          </a:lnRef>
+          <a:fillRef idx="3">
+            <a:schemeClr val="accent1"/>
+          </a:fillRef>
+          <a:effectRef idx="2">
+            <a:schemeClr val="accent1"/>
+          </a:effectRef>
+          <a:fontRef idx="minor">
+            <a:schemeClr val="lt1"/>
+          </a:fontRef>
+        </p:style>
+        <p:txBody>
+          <a:bodyPr rtlCol="0" anchor="ctr"/>
+          <a:lstStyle/>
+          <a:p>
+            <a:pPr algn="ctr"/>
+          </a:p>
+        </p:txBody>
+      </p:sp>
+      <p:sp>
+        <p:nvSpPr>
+          <p:cNvPr id="4" name="TextBox 3"/>
+          <p:cNvSpPr txBox="1"/>
+          <p:nvPr/>
+        </p:nvSpPr>
+        <p:spPr>
+          <a:xfrm>
+            <a:off x="841248" y="347472"/>
+            <a:ext cx="10881360" cy="868680"/>
+          </a:xfrm>
+          <a:prstGeom prst="rect">
+            <a:avLst/>
+          </a:prstGeom>
+          <a:noFill/>
+        </p:spPr>
+        <p:txBody>
+          <a:bodyPr wrap="square" anchor="ctr" lIns="0" rIns="0" tIns="0" bIns="0">
+            <a:spAutoFit/>
+          </a:bodyPr>
+          <a:lstStyle/>
+          <a:p>
+            <a:pPr algn="l"/>
+            <a:r>
+              <a:rPr sz="3300" b="1" i="0">
+                <a:solidFill>
+                  <a:srgbClr val="1B1F2A"/>
+                </a:solidFill>
+                <a:latin typeface="Georgia"/>
+              </a:rPr>
+              <a:t>References</a:t>
+            </a:r>
+          </a:p>
+        </p:txBody>
+      </p:sp>
+      <p:sp>
+        <p:nvSpPr>
+          <p:cNvPr id="5" name="TextBox 4"/>
+          <p:cNvSpPr txBox="1"/>
+          <p:nvPr/>
+        </p:nvSpPr>
+        <p:spPr>
+          <a:xfrm>
+            <a:off x="640080" y="1517904"/>
+            <a:ext cx="5440680" cy="4846320"/>
+          </a:xfrm>
+          <a:prstGeom prst="rect">
+            <a:avLst/>
+          </a:prstGeom>
+          <a:noFill/>
+        </p:spPr>
+        <p:txBody>
+          <a:bodyPr wrap="square" anchor="t" lIns="0" rIns="0" tIns="0" bIns="0">
+            <a:spAutoFit/>
+          </a:bodyPr>
+          <a:lstStyle/>
+          <a:p>
+            <a:pPr algn="l">
+              <a:lnSpc>
+                <a:spcPct val="105000"/>
+              </a:lnSpc>
+              <a:spcAft>
+                <a:spcPts val="900"/>
+              </a:spcAft>
+            </a:pPr>
+            <a:r>
+              <a:rPr sz="1100" b="1" i="0">
+                <a:solidFill>
+                  <a:srgbClr val="5B5BD6"/>
+                </a:solidFill>
+                <a:latin typeface="Arial"/>
+              </a:rPr>
+              <a:t>[1]  </a:t>
+            </a:r>
+            <a:r>
+              <a:rPr sz="1100" b="1" i="0">
+                <a:solidFill>
+                  <a:srgbClr val="1B1F2A"/>
+                </a:solidFill>
+                <a:latin typeface="Arial"/>
+              </a:rPr>
+              <a:t>Kingma &amp; Welling (2014). </a:t>
+            </a:r>
+            <a:r>
+              <a:rPr sz="1100" b="0" i="1">
+                <a:solidFill>
+                  <a:srgbClr val="3C4351"/>
+                </a:solidFill>
+                <a:latin typeface="Arial"/>
+              </a:rPr>
+              <a:t>Auto-Encoding Variational Bayes.  </a:t>
+            </a:r>
+            <a:r>
+              <a:rPr sz="1100" b="0" i="0">
+                <a:solidFill>
+                  <a:srgbClr val="8A909C"/>
+                </a:solidFill>
+                <a:latin typeface="Arial"/>
+              </a:rPr>
+              <a:t>ICLR.</a:t>
+            </a:r>
+          </a:p>
+          <a:p>
+            <a:pPr algn="l">
+              <a:lnSpc>
+                <a:spcPct val="105000"/>
+              </a:lnSpc>
+              <a:spcAft>
+                <a:spcPts val="900"/>
+              </a:spcAft>
+            </a:pPr>
+            <a:r>
+              <a:rPr sz="1100" b="1" i="0">
+                <a:solidFill>
+                  <a:srgbClr val="5B5BD6"/>
+                </a:solidFill>
+                <a:latin typeface="Arial"/>
+              </a:rPr>
+              <a:t>[2]  </a:t>
+            </a:r>
+            <a:r>
+              <a:rPr sz="1100" b="1" i="0">
+                <a:solidFill>
+                  <a:srgbClr val="1B1F2A"/>
+                </a:solidFill>
+                <a:latin typeface="Arial"/>
+              </a:rPr>
+              <a:t>Goodfellow et al. (2014). </a:t>
+            </a:r>
+            <a:r>
+              <a:rPr sz="1100" b="0" i="1">
+                <a:solidFill>
+                  <a:srgbClr val="3C4351"/>
+                </a:solidFill>
+                <a:latin typeface="Arial"/>
+              </a:rPr>
+              <a:t>Generative Adversarial Nets.  </a:t>
+            </a:r>
+            <a:r>
+              <a:rPr sz="1100" b="0" i="0">
+                <a:solidFill>
+                  <a:srgbClr val="8A909C"/>
+                </a:solidFill>
+                <a:latin typeface="Arial"/>
+              </a:rPr>
+              <a:t>NeurIPS.</a:t>
+            </a:r>
+          </a:p>
+          <a:p>
+            <a:pPr algn="l">
+              <a:lnSpc>
+                <a:spcPct val="105000"/>
+              </a:lnSpc>
+              <a:spcAft>
+                <a:spcPts val="900"/>
+              </a:spcAft>
+            </a:pPr>
+            <a:r>
+              <a:rPr sz="1100" b="1" i="0">
+                <a:solidFill>
+                  <a:srgbClr val="5B5BD6"/>
+                </a:solidFill>
+                <a:latin typeface="Arial"/>
+              </a:rPr>
+              <a:t>[3]  </a:t>
+            </a:r>
+            <a:r>
+              <a:rPr sz="1100" b="1" i="0">
+                <a:solidFill>
+                  <a:srgbClr val="1B1F2A"/>
+                </a:solidFill>
+                <a:latin typeface="Arial"/>
+              </a:rPr>
+              <a:t>Rezende &amp; Mohamed (2015). </a:t>
+            </a:r>
+            <a:r>
+              <a:rPr sz="1100" b="0" i="1">
+                <a:solidFill>
+                  <a:srgbClr val="3C4351"/>
+                </a:solidFill>
+                <a:latin typeface="Arial"/>
+              </a:rPr>
+              <a:t>Variational Inference with Normalizing Flows.  </a:t>
+            </a:r>
+            <a:r>
+              <a:rPr sz="1100" b="0" i="0">
+                <a:solidFill>
+                  <a:srgbClr val="8A909C"/>
+                </a:solidFill>
+                <a:latin typeface="Arial"/>
+              </a:rPr>
+              <a:t>ICML.</a:t>
+            </a:r>
+          </a:p>
+          <a:p>
+            <a:pPr algn="l">
+              <a:lnSpc>
+                <a:spcPct val="105000"/>
+              </a:lnSpc>
+              <a:spcAft>
+                <a:spcPts val="900"/>
+              </a:spcAft>
+            </a:pPr>
+            <a:r>
+              <a:rPr sz="1100" b="1" i="0">
+                <a:solidFill>
+                  <a:srgbClr val="5B5BD6"/>
+                </a:solidFill>
+                <a:latin typeface="Arial"/>
+              </a:rPr>
+              <a:t>[4]  </a:t>
+            </a:r>
+            <a:r>
+              <a:rPr sz="1100" b="1" i="0">
+                <a:solidFill>
+                  <a:srgbClr val="1B1F2A"/>
+                </a:solidFill>
+                <a:latin typeface="Arial"/>
+              </a:rPr>
+              <a:t>Hyvärinen (2005). </a:t>
+            </a:r>
+            <a:r>
+              <a:rPr sz="1100" b="0" i="1">
+                <a:solidFill>
+                  <a:srgbClr val="3C4351"/>
+                </a:solidFill>
+                <a:latin typeface="Arial"/>
+              </a:rPr>
+              <a:t>Estimation of Non-Normalized Statistical Models by Score Matching.  </a:t>
+            </a:r>
+            <a:r>
+              <a:rPr sz="1100" b="0" i="0">
+                <a:solidFill>
+                  <a:srgbClr val="8A909C"/>
+                </a:solidFill>
+                <a:latin typeface="Arial"/>
+              </a:rPr>
+              <a:t>JMLR.</a:t>
+            </a:r>
+          </a:p>
+          <a:p>
+            <a:pPr algn="l">
+              <a:lnSpc>
+                <a:spcPct val="105000"/>
+              </a:lnSpc>
+              <a:spcAft>
+                <a:spcPts val="900"/>
+              </a:spcAft>
+            </a:pPr>
+            <a:r>
+              <a:rPr sz="1100" b="1" i="0">
+                <a:solidFill>
+                  <a:srgbClr val="5B5BD6"/>
+                </a:solidFill>
+                <a:latin typeface="Arial"/>
+              </a:rPr>
+              <a:t>[5]  </a:t>
+            </a:r>
+            <a:r>
+              <a:rPr sz="1100" b="1" i="0">
+                <a:solidFill>
+                  <a:srgbClr val="1B1F2A"/>
+                </a:solidFill>
+                <a:latin typeface="Arial"/>
+              </a:rPr>
+              <a:t>Hutchinson (1990). </a:t>
+            </a:r>
+            <a:r>
+              <a:rPr sz="1100" b="0" i="1">
+                <a:solidFill>
+                  <a:srgbClr val="3C4351"/>
+                </a:solidFill>
+                <a:latin typeface="Arial"/>
+              </a:rPr>
+              <a:t>A Stochastic Estimator of the Trace of the Influence Matrix for Laplacian Smoothing Splines.  </a:t>
+            </a:r>
+            <a:r>
+              <a:rPr sz="1100" b="0" i="0">
+                <a:solidFill>
+                  <a:srgbClr val="8A909C"/>
+                </a:solidFill>
+                <a:latin typeface="Arial"/>
+              </a:rPr>
+              <a:t>Commun. Stat. – Simul. Comput..</a:t>
+            </a:r>
+          </a:p>
+          <a:p>
+            <a:pPr algn="l">
+              <a:lnSpc>
+                <a:spcPct val="105000"/>
+              </a:lnSpc>
+              <a:spcAft>
+                <a:spcPts val="900"/>
+              </a:spcAft>
+            </a:pPr>
+            <a:r>
+              <a:rPr sz="1100" b="1" i="0">
+                <a:solidFill>
+                  <a:srgbClr val="5B5BD6"/>
+                </a:solidFill>
+                <a:latin typeface="Arial"/>
+              </a:rPr>
+              <a:t>[6]  </a:t>
+            </a:r>
+            <a:r>
+              <a:rPr sz="1100" b="1" i="0">
+                <a:solidFill>
+                  <a:srgbClr val="1B1F2A"/>
+                </a:solidFill>
+                <a:latin typeface="Arial"/>
+              </a:rPr>
+              <a:t>Song, Garg, Shi &amp; Ermon (2019). </a:t>
+            </a:r>
+            <a:r>
+              <a:rPr sz="1100" b="0" i="1">
+                <a:solidFill>
+                  <a:srgbClr val="3C4351"/>
+                </a:solidFill>
+                <a:latin typeface="Arial"/>
+              </a:rPr>
+              <a:t>Sliced Score Matching: A Scalable Approach to Density and Score Estimation.  </a:t>
+            </a:r>
+            <a:r>
+              <a:rPr sz="1100" b="0" i="0">
+                <a:solidFill>
+                  <a:srgbClr val="8A909C"/>
+                </a:solidFill>
+                <a:latin typeface="Arial"/>
+              </a:rPr>
+              <a:t>UAI.</a:t>
+            </a:r>
+          </a:p>
+          <a:p>
+            <a:pPr algn="l">
+              <a:lnSpc>
+                <a:spcPct val="105000"/>
+              </a:lnSpc>
+              <a:spcAft>
+                <a:spcPts val="900"/>
+              </a:spcAft>
+            </a:pPr>
+            <a:r>
+              <a:rPr sz="1100" b="1" i="0">
+                <a:solidFill>
+                  <a:srgbClr val="5B5BD6"/>
+                </a:solidFill>
+                <a:latin typeface="Arial"/>
+              </a:rPr>
+              <a:t>[7]  </a:t>
+            </a:r>
+            <a:r>
+              <a:rPr sz="1100" b="1" i="0">
+                <a:solidFill>
+                  <a:srgbClr val="1B1F2A"/>
+                </a:solidFill>
+                <a:latin typeface="Arial"/>
+              </a:rPr>
+              <a:t>Vincent, Larochelle, Bengio &amp; Manzagol (2008). </a:t>
+            </a:r>
+            <a:r>
+              <a:rPr sz="1100" b="0" i="1">
+                <a:solidFill>
+                  <a:srgbClr val="3C4351"/>
+                </a:solidFill>
+                <a:latin typeface="Arial"/>
+              </a:rPr>
+              <a:t>Extracting and Composing Robust Features with Denoising Autoencoders.  </a:t>
+            </a:r>
+            <a:r>
+              <a:rPr sz="1100" b="0" i="0">
+                <a:solidFill>
+                  <a:srgbClr val="8A909C"/>
+                </a:solidFill>
+                <a:latin typeface="Arial"/>
+              </a:rPr>
+              <a:t>ICML.</a:t>
+            </a:r>
+          </a:p>
+        </p:txBody>
+      </p:sp>
+      <p:sp>
+        <p:nvSpPr>
+          <p:cNvPr id="6" name="TextBox 5"/>
+          <p:cNvSpPr txBox="1"/>
+          <p:nvPr/>
+        </p:nvSpPr>
+        <p:spPr>
+          <a:xfrm>
+            <a:off x="6263640" y="1517904"/>
+            <a:ext cx="5440680" cy="4846320"/>
+          </a:xfrm>
+          <a:prstGeom prst="rect">
+            <a:avLst/>
+          </a:prstGeom>
+          <a:noFill/>
+        </p:spPr>
+        <p:txBody>
+          <a:bodyPr wrap="square" anchor="t" lIns="0" rIns="0" tIns="0" bIns="0">
+            <a:spAutoFit/>
+          </a:bodyPr>
+          <a:lstStyle/>
+          <a:p>
+            <a:pPr algn="l">
+              <a:lnSpc>
+                <a:spcPct val="105000"/>
+              </a:lnSpc>
+              <a:spcAft>
+                <a:spcPts val="900"/>
+              </a:spcAft>
+            </a:pPr>
+            <a:r>
+              <a:rPr sz="1100" b="1" i="0">
+                <a:solidFill>
+                  <a:srgbClr val="5B5BD6"/>
+                </a:solidFill>
+                <a:latin typeface="Arial"/>
+              </a:rPr>
+              <a:t>[8]  </a:t>
+            </a:r>
+            <a:r>
+              <a:rPr sz="1100" b="1" i="0">
+                <a:solidFill>
+                  <a:srgbClr val="1B1F2A"/>
+                </a:solidFill>
+                <a:latin typeface="Arial"/>
+              </a:rPr>
+              <a:t>Vincent (2011). </a:t>
+            </a:r>
+            <a:r>
+              <a:rPr sz="1100" b="0" i="1">
+                <a:solidFill>
+                  <a:srgbClr val="3C4351"/>
+                </a:solidFill>
+                <a:latin typeface="Arial"/>
+              </a:rPr>
+              <a:t>A Connection Between Score Matching and Denoising Autoencoders.  </a:t>
+            </a:r>
+            <a:r>
+              <a:rPr sz="1100" b="0" i="0">
+                <a:solidFill>
+                  <a:srgbClr val="8A909C"/>
+                </a:solidFill>
+                <a:latin typeface="Arial"/>
+              </a:rPr>
+              <a:t>Neural Computation.</a:t>
+            </a:r>
+          </a:p>
+          <a:p>
+            <a:pPr algn="l">
+              <a:lnSpc>
+                <a:spcPct val="105000"/>
+              </a:lnSpc>
+              <a:spcAft>
+                <a:spcPts val="900"/>
+              </a:spcAft>
+            </a:pPr>
+            <a:r>
+              <a:rPr sz="1100" b="1" i="0">
+                <a:solidFill>
+                  <a:srgbClr val="5B5BD6"/>
+                </a:solidFill>
+                <a:latin typeface="Arial"/>
+              </a:rPr>
+              <a:t>[9]  </a:t>
+            </a:r>
+            <a:r>
+              <a:rPr sz="1100" b="1" i="0">
+                <a:solidFill>
+                  <a:srgbClr val="1B1F2A"/>
+                </a:solidFill>
+                <a:latin typeface="Arial"/>
+              </a:rPr>
+              <a:t>Sohl-Dickstein, Weiss, Maheswaranathan &amp; Ganguli (2015). </a:t>
+            </a:r>
+            <a:r>
+              <a:rPr sz="1100" b="0" i="1">
+                <a:solidFill>
+                  <a:srgbClr val="3C4351"/>
+                </a:solidFill>
+                <a:latin typeface="Arial"/>
+              </a:rPr>
+              <a:t>Deep Unsupervised Learning using Nonequilibrium Thermodynamics.  </a:t>
+            </a:r>
+            <a:r>
+              <a:rPr sz="1100" b="0" i="0">
+                <a:solidFill>
+                  <a:srgbClr val="8A909C"/>
+                </a:solidFill>
+                <a:latin typeface="Arial"/>
+              </a:rPr>
+              <a:t>ICML.</a:t>
+            </a:r>
+          </a:p>
+          <a:p>
+            <a:pPr algn="l">
+              <a:lnSpc>
+                <a:spcPct val="105000"/>
+              </a:lnSpc>
+              <a:spcAft>
+                <a:spcPts val="900"/>
+              </a:spcAft>
+            </a:pPr>
+            <a:r>
+              <a:rPr sz="1100" b="1" i="0">
+                <a:solidFill>
+                  <a:srgbClr val="5B5BD6"/>
+                </a:solidFill>
+                <a:latin typeface="Arial"/>
+              </a:rPr>
+              <a:t>[10]  </a:t>
+            </a:r>
+            <a:r>
+              <a:rPr sz="1100" b="1" i="0">
+                <a:solidFill>
+                  <a:srgbClr val="1B1F2A"/>
+                </a:solidFill>
+                <a:latin typeface="Arial"/>
+              </a:rPr>
+              <a:t>Welling &amp; Teh (2011). </a:t>
+            </a:r>
+            <a:r>
+              <a:rPr sz="1100" b="0" i="1">
+                <a:solidFill>
+                  <a:srgbClr val="3C4351"/>
+                </a:solidFill>
+                <a:latin typeface="Arial"/>
+              </a:rPr>
+              <a:t>Bayesian Learning via Stochastic Gradient Langevin Dynamics.  </a:t>
+            </a:r>
+            <a:r>
+              <a:rPr sz="1100" b="0" i="0">
+                <a:solidFill>
+                  <a:srgbClr val="8A909C"/>
+                </a:solidFill>
+                <a:latin typeface="Arial"/>
+              </a:rPr>
+              <a:t>ICML.</a:t>
+            </a:r>
+          </a:p>
+          <a:p>
+            <a:pPr algn="l">
+              <a:lnSpc>
+                <a:spcPct val="105000"/>
+              </a:lnSpc>
+              <a:spcAft>
+                <a:spcPts val="900"/>
+              </a:spcAft>
+            </a:pPr>
+            <a:r>
+              <a:rPr sz="1100" b="1" i="0">
+                <a:solidFill>
+                  <a:srgbClr val="5B5BD6"/>
+                </a:solidFill>
+                <a:latin typeface="Arial"/>
+              </a:rPr>
+              <a:t>[11]  </a:t>
+            </a:r>
+            <a:r>
+              <a:rPr sz="1100" b="1" i="0">
+                <a:solidFill>
+                  <a:srgbClr val="1B1F2A"/>
+                </a:solidFill>
+                <a:latin typeface="Arial"/>
+              </a:rPr>
+              <a:t>Song &amp; Ermon (2019). </a:t>
+            </a:r>
+            <a:r>
+              <a:rPr sz="1100" b="0" i="1">
+                <a:solidFill>
+                  <a:srgbClr val="3C4351"/>
+                </a:solidFill>
+                <a:latin typeface="Arial"/>
+              </a:rPr>
+              <a:t>Generative Modeling by Estimating Gradients of the Data Distribution.  </a:t>
+            </a:r>
+            <a:r>
+              <a:rPr sz="1100" b="0" i="0">
+                <a:solidFill>
+                  <a:srgbClr val="8A909C"/>
+                </a:solidFill>
+                <a:latin typeface="Arial"/>
+              </a:rPr>
+              <a:t>NeurIPS.</a:t>
+            </a:r>
+          </a:p>
+          <a:p>
+            <a:pPr algn="l">
+              <a:lnSpc>
+                <a:spcPct val="105000"/>
+              </a:lnSpc>
+              <a:spcAft>
+                <a:spcPts val="900"/>
+              </a:spcAft>
+            </a:pPr>
+            <a:r>
+              <a:rPr sz="1100" b="1" i="0">
+                <a:solidFill>
+                  <a:srgbClr val="5B5BD6"/>
+                </a:solidFill>
+                <a:latin typeface="Arial"/>
+              </a:rPr>
+              <a:t>[12]  </a:t>
+            </a:r>
+            <a:r>
+              <a:rPr sz="1100" b="1" i="0">
+                <a:solidFill>
+                  <a:srgbClr val="1B1F2A"/>
+                </a:solidFill>
+                <a:latin typeface="Arial"/>
+              </a:rPr>
+              <a:t>Ho, Jain &amp; Abbeel (2020). </a:t>
+            </a:r>
+            <a:r>
+              <a:rPr sz="1100" b="0" i="1">
+                <a:solidFill>
+                  <a:srgbClr val="3C4351"/>
+                </a:solidFill>
+                <a:latin typeface="Arial"/>
+              </a:rPr>
+              <a:t>Denoising Diffusion Probabilistic Models.  </a:t>
+            </a:r>
+            <a:r>
+              <a:rPr sz="1100" b="0" i="0">
+                <a:solidFill>
+                  <a:srgbClr val="8A909C"/>
+                </a:solidFill>
+                <a:latin typeface="Arial"/>
+              </a:rPr>
+              <a:t>NeurIPS.</a:t>
+            </a:r>
+          </a:p>
+          <a:p>
+            <a:pPr algn="l">
+              <a:lnSpc>
+                <a:spcPct val="105000"/>
+              </a:lnSpc>
+              <a:spcAft>
+                <a:spcPts val="900"/>
+              </a:spcAft>
+            </a:pPr>
+            <a:r>
+              <a:rPr sz="1100" b="1" i="0">
+                <a:solidFill>
+                  <a:srgbClr val="5B5BD6"/>
+                </a:solidFill>
+                <a:latin typeface="Arial"/>
+              </a:rPr>
+              <a:t>[13]  </a:t>
+            </a:r>
+            <a:r>
+              <a:rPr sz="1100" b="1" i="0">
+                <a:solidFill>
+                  <a:srgbClr val="1B1F2A"/>
+                </a:solidFill>
+                <a:latin typeface="Arial"/>
+              </a:rPr>
+              <a:t>Song, Sohl-Dickstein, Kingma, Kumar, Ermon &amp; Poole (2021). </a:t>
+            </a:r>
+            <a:r>
+              <a:rPr sz="1100" b="0" i="1">
+                <a:solidFill>
+                  <a:srgbClr val="3C4351"/>
+                </a:solidFill>
+                <a:latin typeface="Arial"/>
+              </a:rPr>
+              <a:t>Score-Based Generative Modeling through Stochastic Differential Equations.  </a:t>
+            </a:r>
+            <a:r>
+              <a:rPr sz="1100" b="0" i="0">
+                <a:solidFill>
+                  <a:srgbClr val="8A909C"/>
+                </a:solidFill>
+                <a:latin typeface="Arial"/>
+              </a:rPr>
+              <a:t>ICLR.</a:t>
+            </a:r>
+          </a:p>
+        </p:txBody>
+      </p:sp>
+      <p:sp>
+        <p:nvSpPr>
+          <p:cNvPr id="7" name="TextBox 6"/>
+          <p:cNvSpPr txBox="1"/>
+          <p:nvPr/>
+        </p:nvSpPr>
+        <p:spPr>
+          <a:xfrm>
+            <a:off x="10820095" y="6400800"/>
+            <a:ext cx="914400" cy="274320"/>
+          </a:xfrm>
+          <a:prstGeom prst="rect">
+            <a:avLst/>
+          </a:prstGeom>
+          <a:noFill/>
+        </p:spPr>
+        <p:txBody>
+          <a:bodyPr wrap="square" anchor="t" lIns="0" rIns="0" tIns="0" bIns="0">
+            <a:spAutoFit/>
+          </a:bodyPr>
+          <a:lstStyle/>
+          <a:p>
+            <a:pPr algn="r"/>
+            <a:r>
+              <a:rPr sz="900" b="0" i="0" spc="50">
+                <a:solidFill>
+                  <a:srgbClr val="8A909C"/>
+                </a:solidFill>
+                <a:latin typeface="Arial"/>
+              </a:rPr>
+              <a:t>43 / 43</a:t>
             </a:r>
           </a:p>
         </p:txBody>
@@ -25740,6 +26843,41 @@
         </p:nvSpPr>
         <p:spPr>
           <a:xfrm>
+            <a:off x="566928" y="6400800"/>
+            <a:ext cx="6858000" cy="274320"/>
+          </a:xfrm>
+          <a:prstGeom prst="rect">
+            <a:avLst/>
+          </a:prstGeom>
+          <a:noFill/>
+        </p:spPr>
+        <p:txBody>
+          <a:bodyPr wrap="square" anchor="t" lIns="0" rIns="0" tIns="0" bIns="0">
+            <a:spAutoFit/>
+          </a:bodyPr>
+          <a:lstStyle/>
+          <a:p>
+            <a:pPr algn="l"/>
+            <a:r>
+              <a:rPr sz="1000" b="0" i="0" spc="30">
+                <a:solidFill>
+                  <a:srgbClr val="8A909C"/>
+                </a:solidFill>
+                <a:latin typeface="Arial"/>
+              </a:rPr>
+              <a:t>[1]  Kingma &amp; Welling, 2014</a:t>
+            </a:r>
+          </a:p>
+        </p:txBody>
+      </p:sp>
+      <p:sp>
+        <p:nvSpPr>
+          <p:cNvPr id="20" name="TextBox 19"/>
+          <p:cNvSpPr txBox="1"/>
+          <p:nvPr/>
+        </p:nvSpPr>
+        <p:spPr>
+          <a:xfrm>
             <a:off x="10820095" y="6400800"/>
             <a:ext cx="914400" cy="274320"/>
           </a:xfrm>
@@ -25762,7 +26900,7 @@
                 </a:solidFill>
                 <a:latin typeface="Arial"/>
               </a:rPr>
-              <a:t>05 / 42</a:t>
+              <a:t>05 / 43</a:t>
             </a:r>
           </a:p>
         </p:txBody>
@@ -26637,6 +27775,41 @@
         </p:nvSpPr>
         <p:spPr>
           <a:xfrm>
+            <a:off x="566928" y="6400800"/>
+            <a:ext cx="6858000" cy="274320"/>
+          </a:xfrm>
+          <a:prstGeom prst="rect">
+            <a:avLst/>
+          </a:prstGeom>
+          <a:noFill/>
+        </p:spPr>
+        <p:txBody>
+          <a:bodyPr wrap="square" anchor="t" lIns="0" rIns="0" tIns="0" bIns="0">
+            <a:spAutoFit/>
+          </a:bodyPr>
+          <a:lstStyle/>
+          <a:p>
+            <a:pPr algn="l"/>
+            <a:r>
+              <a:rPr sz="1000" b="0" i="0" spc="30">
+                <a:solidFill>
+                  <a:srgbClr val="8A909C"/>
+                </a:solidFill>
+                <a:latin typeface="Arial"/>
+              </a:rPr>
+              <a:t>[2]  Goodfellow et al., 2014</a:t>
+            </a:r>
+          </a:p>
+        </p:txBody>
+      </p:sp>
+      <p:sp>
+        <p:nvSpPr>
+          <p:cNvPr id="23" name="TextBox 22"/>
+          <p:cNvSpPr txBox="1"/>
+          <p:nvPr/>
+        </p:nvSpPr>
+        <p:spPr>
+          <a:xfrm>
             <a:off x="10820095" y="6400800"/>
             <a:ext cx="914400" cy="274320"/>
           </a:xfrm>
@@ -26659,7 +27832,7 @@
                 </a:solidFill>
                 <a:latin typeface="Arial"/>
               </a:rPr>
-              <a:t>06 / 42</a:t>
+              <a:t>06 / 43</a:t>
             </a:r>
           </a:p>
         </p:txBody>
@@ -27462,6 +28635,41 @@
         </p:nvSpPr>
         <p:spPr>
           <a:xfrm>
+            <a:off x="566928" y="6400800"/>
+            <a:ext cx="6858000" cy="274320"/>
+          </a:xfrm>
+          <a:prstGeom prst="rect">
+            <a:avLst/>
+          </a:prstGeom>
+          <a:noFill/>
+        </p:spPr>
+        <p:txBody>
+          <a:bodyPr wrap="square" anchor="t" lIns="0" rIns="0" tIns="0" bIns="0">
+            <a:spAutoFit/>
+          </a:bodyPr>
+          <a:lstStyle/>
+          <a:p>
+            <a:pPr algn="l"/>
+            <a:r>
+              <a:rPr sz="1000" b="0" i="0" spc="30">
+                <a:solidFill>
+                  <a:srgbClr val="8A909C"/>
+                </a:solidFill>
+                <a:latin typeface="Arial"/>
+              </a:rPr>
+              <a:t>[3]  Rezende &amp; Mohamed, 2015</a:t>
+            </a:r>
+          </a:p>
+        </p:txBody>
+      </p:sp>
+      <p:sp>
+        <p:nvSpPr>
+          <p:cNvPr id="21" name="TextBox 20"/>
+          <p:cNvSpPr txBox="1"/>
+          <p:nvPr/>
+        </p:nvSpPr>
+        <p:spPr>
+          <a:xfrm>
             <a:off x="10820095" y="6400800"/>
             <a:ext cx="914400" cy="274320"/>
           </a:xfrm>
@@ -27484,7 +28692,7 @@
                 </a:solidFill>
                 <a:latin typeface="Arial"/>
               </a:rPr>
-              <a:t>07 / 42</a:t>
+              <a:t>07 / 43</a:t>
             </a:r>
           </a:p>
         </p:txBody>
@@ -29015,7 +30223,7 @@
                 </a:solidFill>
                 <a:latin typeface="Arial"/>
               </a:rPr>
-              <a:t>08 / 42</a:t>
+              <a:t>08 / 43</a:t>
             </a:r>
           </a:p>
         </p:txBody>

</xml_diff>

<commit_message>
Update Motivation deck (deck 1) to latest version; bump cache to v3
</commit_message>
<xml_diff>
--- a/diffusion/diffusion_models_polished.pptx
+++ b/diffusion/diffusion_models_polished.pptx
@@ -3339,6 +3339,76 @@
           </a:prstGeom>
         </p:spPr>
       </p:pic>
+      <p:sp>
+        <p:nvSpPr>
+          <p:cNvPr id="7" name="TextBox 6"/>
+          <p:cNvSpPr txBox="1"/>
+          <p:nvPr/>
+        </p:nvSpPr>
+        <p:spPr>
+          <a:xfrm>
+            <a:off x="0" y="5943600"/>
+            <a:ext cx="12188952" cy="320040"/>
+          </a:xfrm>
+          <a:prstGeom prst="rect">
+            <a:avLst/>
+          </a:prstGeom>
+          <a:noFill/>
+        </p:spPr>
+        <p:txBody>
+          <a:bodyPr wrap="square" lIns="0" rIns="0" tIns="0" bIns="0">
+            <a:spAutoFit/>
+          </a:bodyPr>
+          <a:lstStyle/>
+          <a:p>
+            <a:pPr algn="ctr"/>
+            <a:r>
+              <a:rPr sz="1600" b="1">
+                <a:solidFill>
+                  <a:srgbClr val="1B1F2A"/>
+                </a:solidFill>
+                <a:latin typeface="Arial"/>
+              </a:rPr>
+              <a:t>Sudarshan Babu</a:t>
+            </a:r>
+          </a:p>
+        </p:txBody>
+      </p:sp>
+      <p:sp>
+        <p:nvSpPr>
+          <p:cNvPr id="8" name="TextBox 7"/>
+          <p:cNvSpPr txBox="1"/>
+          <p:nvPr/>
+        </p:nvSpPr>
+        <p:spPr>
+          <a:xfrm>
+            <a:off x="0" y="6355080"/>
+            <a:ext cx="12188952" cy="274320"/>
+          </a:xfrm>
+          <a:prstGeom prst="rect">
+            <a:avLst/>
+          </a:prstGeom>
+          <a:noFill/>
+        </p:spPr>
+        <p:txBody>
+          <a:bodyPr wrap="square" lIns="0" rIns="0" tIns="0" bIns="0">
+            <a:spAutoFit/>
+          </a:bodyPr>
+          <a:lstStyle/>
+          <a:p>
+            <a:pPr algn="ctr"/>
+            <a:r>
+              <a:rPr sz="1150" b="0" i="1">
+                <a:solidFill>
+                  <a:srgbClr val="8A909C"/>
+                </a:solidFill>
+                <a:latin typeface="Arial"/>
+              </a:rPr>
+              <a:t>Slides created using Claude and Manus AI — each slide was prompted by the author.</a:t>
+            </a:r>
+          </a:p>
+        </p:txBody>
+      </p:sp>
     </p:spTree>
   </p:cSld>
   <p:clrMapOvr>

</xml_diff>